<commit_message>
Refine technical credibility, add validation matrix, interactive Socratic prompt, and update pitch deck
</commit_message>
<xml_diff>
--- a/submission/iQOO_EdgeTutor_PitchDeck.pptx
+++ b/submission/iQOO_EdgeTutor_PitchDeck.pptx
@@ -10,8 +10,6 @@
     <p:sldId id="258" r:id="rId9"/>
     <p:sldId id="259" r:id="rId10"/>
     <p:sldId id="260" r:id="rId11"/>
-    <p:sldId id="261" r:id="rId12"/>
-    <p:sldId id="262" r:id="rId13"/>
   </p:sldIdLst>
   <p:sldSz cx="12191695" cy="6858000" type="screen4x3"/>
   <p:notesSz cx="6858000" cy="9144000"/>
@@ -3190,7 +3188,7 @@
         </p:nvSpPr>
         <p:spPr>
           <a:xfrm>
-            <a:off x="731520" y="914400"/>
+            <a:off x="731520" y="822960"/>
             <a:ext cx="10698480" cy="2011680"/>
           </a:xfrm>
           <a:prstGeom prst="rect">
@@ -3227,7 +3225,7 @@
               </a:defRPr>
             </a:pPr>
             <a:r>
-              <a:t>100% Offline, On-Device AI Educational Mentor in Airplane Mode</a:t>
+              <a:t>What If Your Smartphone Could Tutor You with Zero Internet?</a:t>
             </a:r>
           </a:p>
           <a:p>
@@ -3242,7 +3240,7 @@
               </a:defRPr>
             </a:pPr>
             <a:r>
-              <a:t>Turning iQOO Gaming Silicon into India's Most Powerful Distraction-Free AI Study Station</a:t>
+              <a:t>An On-Device AI Mentor for CBSE 9-10 &amp; JEE Problem Solving in 100% Airplane Mode</a:t>
             </a:r>
           </a:p>
         </p:txBody>
@@ -3255,8 +3253,8 @@
         </p:nvSpPr>
         <p:spPr>
           <a:xfrm>
-            <a:off x="731520" y="3200400"/>
-            <a:ext cx="3291840" cy="2194560"/>
+            <a:off x="731520" y="3108960"/>
+            <a:ext cx="3291840" cy="2286000"/>
           </a:xfrm>
           <a:prstGeom prst="roundRect">
             <a:avLst/>
@@ -3291,12 +3289,12 @@
             <a:pPr algn="ctr">
               <a:defRPr sz="1600" b="1">
                 <a:solidFill>
-                  <a:srgbClr val="00E676"/>
+                  <a:srgbClr val="FF3E00"/>
                 </a:solidFill>
               </a:defRPr>
             </a:pPr>
             <a:r>
-              <a:t>✈️ Pure Airplane Mode</a:t>
+              <a:t>📷 1. Offline Camera Scan</a:t>
             </a:r>
           </a:p>
           <a:p>
@@ -3311,15 +3309,15 @@
               </a:defRPr>
             </a:pPr>
             <a:r>
-              <a:t>• Zero internet permission (0 KB data)</a:t>
+              <a:t>• Point camera at printed textbook problem</a:t>
             </a:r>
             <a:br/>
             <a:r>
-              <a:t>• No Instagram / WhatsApp notifications</a:t>
+              <a:t>• Local Google ML Kit text extraction</a:t>
             </a:r>
             <a:br/>
             <a:r>
-              <a:t>• 100% private: Doubts never leave phone</a:t>
+              <a:t>• Zero internet permission (0 KB Air-Gapped)</a:t>
             </a:r>
           </a:p>
         </p:txBody>
@@ -3332,8 +3330,8 @@
         </p:nvSpPr>
         <p:spPr>
           <a:xfrm>
-            <a:off x="4389120" y="3200400"/>
-            <a:ext cx="3291840" cy="2194560"/>
+            <a:off x="4389120" y="3108960"/>
+            <a:ext cx="3291840" cy="2286000"/>
           </a:xfrm>
           <a:prstGeom prst="roundRect">
             <a:avLst/>
@@ -3368,12 +3366,12 @@
             <a:pPr algn="ctr">
               <a:defRPr sz="1600" b="1">
                 <a:solidFill>
-                  <a:srgbClr val="F7B500"/>
+                  <a:srgbClr val="00E5FF"/>
                 </a:solidFill>
               </a:defRPr>
             </a:pPr>
             <a:r>
-              <a:t>⚡ Sub-Second Speed</a:t>
+              <a:t>🧠 2. On-Device Reasoning</a:t>
             </a:r>
           </a:p>
           <a:p>
@@ -3388,15 +3386,15 @@
               </a:defRPr>
             </a:pPr>
             <a:r>
-              <a:t>• Snapdragon Hexagon NPU offload</a:t>
+              <a:t>• Embedded NCERT curriculum vault</a:t>
             </a:r>
             <a:br/>
             <a:r>
-              <a:t>• 77 GB/s LPDDR5X RAM bandwidth</a:t>
+              <a:t>• Small Language Model (SLM) reasoning</a:t>
             </a:r>
             <a:br/>
             <a:r>
-              <a:t>• Socratic steps in &lt; 800ms vs 8s cloud</a:t>
+              <a:t>• Grounded in CBSE standards (No hallucinations)</a:t>
             </a:r>
           </a:p>
         </p:txBody>
@@ -3409,8 +3407,8 @@
         </p:nvSpPr>
         <p:spPr>
           <a:xfrm>
-            <a:off x="8046720" y="3200400"/>
-            <a:ext cx="3291840" cy="2194560"/>
+            <a:off x="8046720" y="3108960"/>
+            <a:ext cx="3291840" cy="2286000"/>
           </a:xfrm>
           <a:prstGeom prst="roundRect">
             <a:avLst/>
@@ -3445,12 +3443,12 @@
             <a:pPr algn="ctr">
               <a:defRPr sz="1600" b="1">
                 <a:solidFill>
-                  <a:srgbClr val="00E5FF"/>
+                  <a:srgbClr val="00E676"/>
                 </a:solidFill>
               </a:defRPr>
             </a:pPr>
             <a:r>
-              <a:t>📚 CBSE &amp; JEE Aligned</a:t>
+              <a:t>💬 3. Socratic Mentorship</a:t>
             </a:r>
           </a:p>
           <a:p>
@@ -3465,15 +3463,15 @@
               </a:defRPr>
             </a:pPr>
             <a:r>
-              <a:t>• Class 9-10 CBSE &amp; Class 11-12 JEE</a:t>
+              <a:t>• Teaches derivation step-by-step</a:t>
             </a:r>
             <a:br/>
             <a:r>
-              <a:t>• Pre-indexed NCERT offline knowledge vault</a:t>
+              <a:t>• Asks probing questions, doesn't dump answers</a:t>
             </a:r>
             <a:br/>
             <a:r>
-              <a:t>• Free forever for students (₹0 cloud bills)</a:t>
+              <a:t>• KaTeX formatted math symbols &amp; formulas</a:t>
             </a:r>
           </a:p>
         </p:txBody>
@@ -3486,7 +3484,7 @@
         </p:nvSpPr>
         <p:spPr>
           <a:xfrm>
-            <a:off x="731520" y="5669280"/>
+            <a:off x="731520" y="5715000"/>
             <a:ext cx="10698480" cy="731520"/>
           </a:xfrm>
           <a:prstGeom prst="rect">
@@ -3641,7 +3639,7 @@
               </a:defRPr>
             </a:pPr>
             <a:r>
-              <a:t>The Real-World Problem: Why Online EdTech Fails Students</a:t>
+              <a:t>The Real Problem: Why Online EdTech Fails Students</a:t>
             </a:r>
           </a:p>
         </p:txBody>
@@ -3690,12 +3688,12 @@
             <a:pPr algn="ctr">
               <a:defRPr sz="1600" b="1">
                 <a:solidFill>
-                  <a:srgbClr val="FF1744"/>
+                  <a:srgbClr val="FF3E00"/>
                 </a:solidFill>
               </a:defRPr>
             </a:pPr>
             <a:r>
-              <a:t>📱 The Distraction Trap</a:t>
+              <a:t>📶 1. The Connectivity Drop</a:t>
             </a:r>
           </a:p>
           <a:p>
@@ -3710,7 +3708,7 @@
               </a:defRPr>
             </a:pPr>
             <a:r>
-              <a:t>When students go online to clear doubts, social notifications (Instagram, WhatsApp, YouTube) shatter their concentration. Deep study requires isolation, but cloud AI demands an active internet connection.</a:t>
+              <a:t>Cloud-dependent AI fails in college hostels, remote towns, or daily train commutes. When students study late at night and connection drops, learning halts completely.</a:t>
             </a:r>
           </a:p>
         </p:txBody>
@@ -3759,12 +3757,12 @@
             <a:pPr algn="ctr">
               <a:defRPr sz="1600" b="1">
                 <a:solidFill>
-                  <a:srgbClr val="FF3E00"/>
+                  <a:srgbClr val="FF1744"/>
                 </a:solidFill>
               </a:defRPr>
             </a:pPr>
             <a:r>
-              <a:t>📶 Connectivity &amp; Coverage Barrier</a:t>
+              <a:t>📱 2. The Distraction Trap</a:t>
             </a:r>
           </a:p>
           <a:p>
@@ -3779,7 +3777,7 @@
               </a:defRPr>
             </a:pPr>
             <a:r>
-              <a:t>Over 300M students in Tier-2/3 cities, rural villages, hostel rooms, or train commutes face unreliable or zero internet. During exams or late-night study, cloud apps completely freeze or fail.</a:t>
+              <a:t>Opening a browser to check a doubt exposes students to social notifications (Instagram, WhatsApp, YouTube). Deep study requires focused isolation, but cloud AI demands active connectivity.</a:t>
             </a:r>
           </a:p>
         </p:txBody>
@@ -3833,7 +3831,7 @@
               </a:defRPr>
             </a:pPr>
             <a:r>
-              <a:t>💰 Prohibitive Server &amp; Subscription Costs</a:t>
+              <a:t>📋 3. Answer-Dumping vs. True Learning</a:t>
             </a:r>
           </a:p>
           <a:p>
@@ -3848,7 +3846,7 @@
               </a:defRPr>
             </a:pPr>
             <a:r>
-              <a:t>Cloud AI services charge ₹1,000–₹2,000/month or incur massive API token bills for manufacturers. EdTech companies cannot sustain free unlimited AI queries for millions of students without bleeding money.</a:t>
+              <a:t>Current cloud tools act as homework copy-pasters. They dump final answers instantly without guiding the student through the fundamental physical derivations and problem-solving steps.</a:t>
             </a:r>
           </a:p>
         </p:txBody>
@@ -3946,7 +3944,7 @@
               </a:defRPr>
             </a:pPr>
             <a:r>
-              <a:t>02 / THE SOLUTION</a:t>
+              <a:t>02 / SYSTEM ARCHITECTURE</a:t>
             </a:r>
           </a:p>
         </p:txBody>
@@ -3981,7 +3979,7 @@
               </a:defRPr>
             </a:pPr>
             <a:r>
-              <a:t>The EdgeTutor Paradigm: Zero-Cloud, 100% On-Device AI</a:t>
+              <a:t>How It Works: End-to-End On-Device Pipeline</a:t>
             </a:r>
           </a:p>
         </p:txBody>
@@ -3995,7 +3993,7 @@
         <p:spPr>
           <a:xfrm>
             <a:off x="731520" y="1645920"/>
-            <a:ext cx="5212080" cy="2011680"/>
+            <a:ext cx="2057400" cy="4389120"/>
           </a:xfrm>
           <a:prstGeom prst="roundRect">
             <a:avLst/>
@@ -4028,29 +4026,37 @@
           <a:lstStyle/>
           <a:p>
             <a:pPr algn="ctr">
-              <a:defRPr sz="1600" b="1">
-                <a:solidFill>
-                  <a:srgbClr val="00E676"/>
+              <a:defRPr sz="1500" b="1">
+                <a:solidFill>
+                  <a:srgbClr val="FF3E00"/>
                 </a:solidFill>
               </a:defRPr>
             </a:pPr>
             <a:r>
-              <a:t>✈️ 100% Airplane Mode Ready</a:t>
+              <a:t>Step 1: Vision</a:t>
             </a:r>
           </a:p>
           <a:p>
             <a:pPr>
               <a:spcBef>
-                <a:spcPts val="600"/>
+                <a:spcPts val="1200"/>
               </a:spcBef>
-              <a:defRPr sz="1200">
-                <a:solidFill>
-                  <a:srgbClr val="A5AFC3"/>
+              <a:defRPr sz="1100">
+                <a:solidFill>
+                  <a:srgbClr val="FFFFFF"/>
                 </a:solidFill>
               </a:defRPr>
             </a:pPr>
             <a:r>
-              <a:t>The app operates with strictly zero internet permissions in AndroidManifest.xml. It guarantees 0 KB network consumption, ensuring pure focus and complete data privacy.</a:t>
+              <a:t>CameraX (Airplane Mode)</a:t>
+            </a:r>
+            <a:br/>
+            <a:r>
+              <a:t>On-device Optical Scanner</a:t>
+            </a:r>
+            <a:br/>
+            <a:r>
+              <a:t>Zero network permission</a:t>
             </a:r>
           </a:p>
         </p:txBody>
@@ -4063,8 +4069,8 @@
         </p:nvSpPr>
         <p:spPr>
           <a:xfrm>
-            <a:off x="6217920" y="1645920"/>
-            <a:ext cx="5212080" cy="2011680"/>
+            <a:off x="2926080" y="1645920"/>
+            <a:ext cx="2057400" cy="4389120"/>
           </a:xfrm>
           <a:prstGeom prst="roundRect">
             <a:avLst/>
@@ -4097,29 +4103,37 @@
           <a:lstStyle/>
           <a:p>
             <a:pPr algn="ctr">
-              <a:defRPr sz="1600" b="1">
+              <a:defRPr sz="1500" b="1">
                 <a:solidFill>
                   <a:srgbClr val="F7B500"/>
                 </a:solidFill>
               </a:defRPr>
             </a:pPr>
             <a:r>
-              <a:t>⚡ Sub-Second Socratic Steps</a:t>
+              <a:t>Step 2: Local OCR</a:t>
             </a:r>
           </a:p>
           <a:p>
             <a:pPr>
               <a:spcBef>
-                <a:spcPts val="600"/>
+                <a:spcPts val="1200"/>
               </a:spcBef>
-              <a:defRPr sz="1200">
-                <a:solidFill>
-                  <a:srgbClr val="A5AFC3"/>
+              <a:defRPr sz="1100">
+                <a:solidFill>
+                  <a:srgbClr val="FFFFFF"/>
                 </a:solidFill>
               </a:defRPr>
             </a:pPr>
             <a:r>
-              <a:t>Instead of dumping whole answers, EdgeTutor acts as an interactive coach. It gives step-by-step guidance, formula definitions, and exam traps in under 800 milliseconds.</a:t>
+              <a:t>Google ML Kit (Offline)</a:t>
+            </a:r>
+            <a:br/>
+            <a:r>
+              <a:t>Extracts formulas &amp; text</a:t>
+            </a:r>
+            <a:br/>
+            <a:r>
+              <a:t>Runs fully in memory</a:t>
             </a:r>
           </a:p>
         </p:txBody>
@@ -4132,8 +4146,8 @@
         </p:nvSpPr>
         <p:spPr>
           <a:xfrm>
-            <a:off x="731520" y="3931920"/>
-            <a:ext cx="5212080" cy="2011680"/>
+            <a:off x="5120640" y="1645920"/>
+            <a:ext cx="2057400" cy="4389120"/>
           </a:xfrm>
           <a:prstGeom prst="roundRect">
             <a:avLst/>
@@ -4166,29 +4180,37 @@
           <a:lstStyle/>
           <a:p>
             <a:pPr algn="ctr">
-              <a:defRPr sz="1600" b="1">
-                <a:solidFill>
-                  <a:srgbClr val="00E5FF"/>
+              <a:defRPr sz="1500" b="1">
+                <a:solidFill>
+                  <a:srgbClr val="A855F7"/>
                 </a:solidFill>
               </a:defRPr>
             </a:pPr>
             <a:r>
-              <a:t>📚 Built-in Indian Curriculum Vault</a:t>
+              <a:t>Step 3: Curriculum RAG</a:t>
             </a:r>
           </a:p>
           <a:p>
             <a:pPr>
               <a:spcBef>
-                <a:spcPts val="600"/>
+                <a:spcPts val="1200"/>
               </a:spcBef>
-              <a:defRPr sz="1200">
-                <a:solidFill>
-                  <a:srgbClr val="A5AFC3"/>
+              <a:defRPr sz="1100">
+                <a:solidFill>
+                  <a:srgbClr val="FFFFFF"/>
                 </a:solidFill>
               </a:defRPr>
             </a:pPr>
             <a:r>
-              <a:t>Class 9-10 CBSE Science &amp; Math, plus Class 11-12 JEE Physics, Chemistry, and Calculus pre-indexed into a lightweight local knowledge base with instant search.</a:t>
+              <a:t>NCERT Knowledge Vault</a:t>
+            </a:r>
+            <a:br/>
+            <a:r>
+              <a:t>CBSE 9-10 &amp; JEE 11-12</a:t>
+            </a:r>
+            <a:br/>
+            <a:r>
+              <a:t>Prevents hallucinations</a:t>
             </a:r>
           </a:p>
         </p:txBody>
@@ -4201,8 +4223,8 @@
         </p:nvSpPr>
         <p:spPr>
           <a:xfrm>
-            <a:off x="6217920" y="3931920"/>
-            <a:ext cx="5212080" cy="2011680"/>
+            <a:off x="7315199" y="1645920"/>
+            <a:ext cx="2057400" cy="4389120"/>
           </a:xfrm>
           <a:prstGeom prst="roundRect">
             <a:avLst/>
@@ -4235,29 +4257,114 @@
           <a:lstStyle/>
           <a:p>
             <a:pPr algn="ctr">
-              <a:defRPr sz="1600" b="1">
-                <a:solidFill>
-                  <a:srgbClr val="FFFFFF"/>
+              <a:defRPr sz="1500" b="1">
+                <a:solidFill>
+                  <a:srgbClr val="00E5FF"/>
                 </a:solidFill>
               </a:defRPr>
             </a:pPr>
             <a:r>
-              <a:t>🆓 Free Forever For Everyone</a:t>
+              <a:t>Step 4: SLM Engine</a:t>
             </a:r>
           </a:p>
           <a:p>
             <a:pPr>
               <a:spcBef>
-                <a:spcPts val="600"/>
+                <a:spcPts val="1200"/>
               </a:spcBef>
-              <a:defRPr sz="1200">
-                <a:solidFill>
-                  <a:srgbClr val="A5AFC3"/>
+              <a:defRPr sz="1100">
+                <a:solidFill>
+                  <a:srgbClr val="FFFFFF"/>
                 </a:solidFill>
               </a:defRPr>
             </a:pPr>
             <a:r>
-              <a:t>Because compute runs 100% locally on the student's iQOO device, iQOO pays ₹0 in cloud server infrastructure, and students get free, unlimited offline tutoring for life.</a:t>
+              <a:t>Quantized Local Model</a:t>
+            </a:r>
+            <a:br/>
+            <a:r>
+              <a:t>Gemma 2B / Phi-3.5 target</a:t>
+            </a:r>
+            <a:br/>
+            <a:r>
+              <a:t>Socratic step generation</a:t>
+            </a:r>
+          </a:p>
+        </p:txBody>
+      </p:sp>
+      <p:sp>
+        <p:nvSpPr>
+          <p:cNvPr id="9" name="Rounded Rectangle 8"/>
+          <p:cNvSpPr/>
+          <p:nvPr/>
+        </p:nvSpPr>
+        <p:spPr>
+          <a:xfrm>
+            <a:off x="9509760" y="1645920"/>
+            <a:ext cx="2057400" cy="4389120"/>
+          </a:xfrm>
+          <a:prstGeom prst="roundRect">
+            <a:avLst/>
+          </a:prstGeom>
+          <a:solidFill>
+            <a:srgbClr val="10141E"/>
+          </a:solidFill>
+          <a:ln w="19050">
+            <a:solidFill>
+              <a:srgbClr val="262D41"/>
+            </a:solidFill>
+          </a:ln>
+        </p:spPr>
+        <p:style>
+          <a:lnRef idx="1">
+            <a:schemeClr val="accent1"/>
+          </a:lnRef>
+          <a:fillRef idx="3">
+            <a:schemeClr val="accent1"/>
+          </a:fillRef>
+          <a:effectRef idx="2">
+            <a:schemeClr val="accent1"/>
+          </a:effectRef>
+          <a:fontRef idx="minor">
+            <a:schemeClr val="lt1"/>
+          </a:fontRef>
+        </p:style>
+        <p:txBody>
+          <a:bodyPr rtlCol="0" anchor="ctr" wrap="square"/>
+          <a:lstStyle/>
+          <a:p>
+            <a:pPr algn="ctr">
+              <a:defRPr sz="1500" b="1">
+                <a:solidFill>
+                  <a:srgbClr val="00E676"/>
+                </a:solidFill>
+              </a:defRPr>
+            </a:pPr>
+            <a:r>
+              <a:t>Step 5: Socratic UI</a:t>
+            </a:r>
+          </a:p>
+          <a:p>
+            <a:pPr>
+              <a:spcBef>
+                <a:spcPts val="1200"/>
+              </a:spcBef>
+              <a:defRPr sz="1100">
+                <a:solidFill>
+                  <a:srgbClr val="FFFFFF"/>
+                </a:solidFill>
+              </a:defRPr>
+            </a:pPr>
+            <a:r>
+              <a:t>Interactive Student Turn</a:t>
+            </a:r>
+            <a:br/>
+            <a:r>
+              <a:t>KaTeX math typesetting</a:t>
+            </a:r>
+            <a:br/>
+            <a:r>
+              <a:t>Guided understanding</a:t>
             </a:r>
           </a:p>
         </p:txBody>
@@ -4355,7 +4462,7 @@
               </a:defRPr>
             </a:pPr>
             <a:r>
-              <a:t>03 / HARDWARE ARCHITECTURE</a:t>
+              <a:t>03 / HARDWARE &amp; VALIDATION</a:t>
             </a:r>
           </a:p>
         </p:txBody>
@@ -4390,7 +4497,7 @@
               </a:defRPr>
             </a:pPr>
             <a:r>
-              <a:t>Hardware Synergy: Unlocking iQOO Gaming Silicon for AI</a:t>
+              <a:t>Hardware Synergy &amp; Implementation Validation Matrix</a:t>
             </a:r>
           </a:p>
         </p:txBody>
@@ -4404,7 +4511,7 @@
         <p:spPr>
           <a:xfrm>
             <a:off x="731520" y="1645920"/>
-            <a:ext cx="3383280" cy="4389120"/>
+            <a:ext cx="4846320" cy="4572000"/>
           </a:xfrm>
           <a:prstGeom prst="roundRect">
             <a:avLst/>
@@ -4437,44 +4544,60 @@
           <a:lstStyle/>
           <a:p>
             <a:pPr algn="ctr">
-              <a:defRPr sz="1700" b="1">
-                <a:solidFill>
-                  <a:srgbClr val="00E5FF"/>
+              <a:defRPr sz="1600" b="1">
+                <a:solidFill>
+                  <a:srgbClr val="F7B500"/>
                 </a:solidFill>
               </a:defRPr>
             </a:pPr>
             <a:r>
-              <a:t>Qualcomm Hexagon NPU</a:t>
+              <a:t>⚡ Why iQOO Hardware Fits Edge AI</a:t>
             </a:r>
           </a:p>
           <a:p>
             <a:pPr>
               <a:spcBef>
-                <a:spcPts val="400"/>
+                <a:spcPts val="800"/>
               </a:spcBef>
-              <a:defRPr sz="1000" b="1">
-                <a:solidFill>
-                  <a:srgbClr val="A5AFC3"/>
+              <a:defRPr sz="1100">
+                <a:solidFill>
+                  <a:srgbClr val="FFFFFF"/>
                 </a:solidFill>
               </a:defRPr>
             </a:pPr>
             <a:r>
-              <a:t>DEDICATED NEURAL PROCESSING</a:t>
-            </a:r>
-          </a:p>
-          <a:p>
-            <a:pPr>
-              <a:spcBef>
-                <a:spcPts val="1400"/>
-              </a:spcBef>
-              <a:defRPr sz="1200">
-                <a:solidFill>
-                  <a:srgbClr val="FFFFFF"/>
-                </a:solidFill>
-              </a:defRPr>
-            </a:pPr>
-            <a:r>
-              <a:t>INT4 / INT8 quantized neural acceleration runs LLM tokens locally with ultra-low 0.8W power draw. Battery lasts all day.</a:t>
+              <a:t>1. High-Bandwidth Memory (LPDDR5X up to 77 GB/s):</a:t>
+            </a:r>
+            <a:br/>
+            <a:r>
+              <a:t>   Overcomes the memory-bandwidth wall for responsive autoregressive token generation.</a:t>
+            </a:r>
+            <a:br/>
+            <a:br/>
+            <a:r>
+              <a:t>2. Qualcomm Hexagon NPU Target:</a:t>
+            </a:r>
+            <a:br/>
+            <a:r>
+              <a:t>   Specialized INT4 quantized matrix multiplication offload at sub-watt power efficiency.</a:t>
+            </a:r>
+            <a:br/>
+            <a:br/>
+            <a:r>
+              <a:t>3. 6000mm² Vapor Chamber Cooling:</a:t>
+            </a:r>
+            <a:br/>
+            <a:r>
+              <a:t>   Provides thermal headroom to prevent throttling during long study sessions.</a:t>
+            </a:r>
+            <a:br/>
+            <a:br/>
+            <a:r>
+              <a:t>4. Airplane Mode Resilience:</a:t>
+            </a:r>
+            <a:br/>
+            <a:r>
+              <a:t>   Proves gaming performance can power serious student productivity.</a:t>
             </a:r>
           </a:p>
         </p:txBody>
@@ -4487,8 +4610,8 @@
         </p:nvSpPr>
         <p:spPr>
           <a:xfrm>
-            <a:off x="4389120" y="1645920"/>
-            <a:ext cx="3383280" cy="4389120"/>
+            <a:off x="5943600" y="1645920"/>
+            <a:ext cx="5486400" cy="4572000"/>
           </a:xfrm>
           <a:prstGeom prst="roundRect">
             <a:avLst/>
@@ -4521,717 +4644,29 @@
           <a:lstStyle/>
           <a:p>
             <a:pPr algn="ctr">
-              <a:defRPr sz="1700" b="1">
-                <a:solidFill>
-                  <a:srgbClr val="F7B500"/>
+              <a:defRPr sz="1600" b="1">
+                <a:solidFill>
+                  <a:srgbClr val="00E5FF"/>
                 </a:solidFill>
               </a:defRPr>
             </a:pPr>
             <a:r>
-              <a:t>77 GB/s LPDDR5X RAM</a:t>
-            </a:r>
-          </a:p>
-          <a:p>
-            <a:pPr>
-              <a:spcBef>
-                <a:spcPts val="400"/>
-              </a:spcBef>
-              <a:defRPr sz="1000" b="1">
-                <a:solidFill>
-                  <a:srgbClr val="A5AFC3"/>
-                </a:solidFill>
-              </a:defRPr>
-            </a:pPr>
-            <a:r>
-              <a:t>OVERCOMING THE MEMORY WALL</a:t>
-            </a:r>
-          </a:p>
-          <a:p>
-            <a:pPr>
-              <a:spcBef>
-                <a:spcPts val="1400"/>
-              </a:spcBef>
-              <a:defRPr sz="1200">
-                <a:solidFill>
-                  <a:srgbClr val="FFFFFF"/>
-                </a:solidFill>
-              </a:defRPr>
-            </a:pPr>
-            <a:r>
-              <a:t>LLM inference is memory-bandwidth bound. iQOO's blazing 77 GB/s bus ensures instant token generation (24+ tok/s) without lag.</a:t>
-            </a:r>
-          </a:p>
-        </p:txBody>
-      </p:sp>
-      <p:sp>
-        <p:nvSpPr>
-          <p:cNvPr id="7" name="Rounded Rectangle 6"/>
-          <p:cNvSpPr/>
-          <p:nvPr/>
-        </p:nvSpPr>
-        <p:spPr>
-          <a:xfrm>
-            <a:off x="8046720" y="1645920"/>
-            <a:ext cx="3383280" cy="4389120"/>
-          </a:xfrm>
-          <a:prstGeom prst="roundRect">
-            <a:avLst/>
-          </a:prstGeom>
-          <a:solidFill>
-            <a:srgbClr val="10141E"/>
-          </a:solidFill>
-          <a:ln w="19050">
-            <a:solidFill>
-              <a:srgbClr val="262D41"/>
-            </a:solidFill>
-          </a:ln>
-        </p:spPr>
-        <p:style>
-          <a:lnRef idx="1">
-            <a:schemeClr val="accent1"/>
-          </a:lnRef>
-          <a:fillRef idx="3">
-            <a:schemeClr val="accent1"/>
-          </a:fillRef>
-          <a:effectRef idx="2">
-            <a:schemeClr val="accent1"/>
-          </a:effectRef>
-          <a:fontRef idx="minor">
-            <a:schemeClr val="lt1"/>
-          </a:fontRef>
-        </p:style>
-        <p:txBody>
-          <a:bodyPr rtlCol="0" anchor="ctr" wrap="square"/>
-          <a:lstStyle/>
-          <a:p>
-            <a:pPr algn="ctr">
-              <a:defRPr sz="1700" b="1">
-                <a:solidFill>
-                  <a:srgbClr val="00E676"/>
-                </a:solidFill>
-              </a:defRPr>
-            </a:pPr>
-            <a:r>
-              <a:t>6000mm² Vapor Chamber</a:t>
-            </a:r>
-          </a:p>
-          <a:p>
-            <a:pPr>
-              <a:spcBef>
-                <a:spcPts val="400"/>
-              </a:spcBef>
-              <a:defRPr sz="1000" b="1">
-                <a:solidFill>
-                  <a:srgbClr val="A5AFC3"/>
-                </a:solidFill>
-              </a:defRPr>
-            </a:pPr>
-            <a:r>
-              <a:t>ZERO THERMAL THROTTLING</a:t>
-            </a:r>
-          </a:p>
-          <a:p>
-            <a:pPr>
-              <a:spcBef>
-                <a:spcPts val="1400"/>
-              </a:spcBef>
-              <a:defRPr sz="1200">
-                <a:solidFill>
-                  <a:srgbClr val="FFFFFF"/>
-                </a:solidFill>
-              </a:defRPr>
-            </a:pPr>
-            <a:r>
-              <a:t>Built for intense BGMI gaming, the aircraft-grade VC heat dissipation keeps the NPU cool during heavy student study sessions.</a:t>
-            </a:r>
-          </a:p>
-        </p:txBody>
-      </p:sp>
-    </p:spTree>
-  </p:cSld>
-  <p:clrMapOvr>
-    <a:masterClrMapping/>
-  </p:clrMapOvr>
-</p:sld>
-</file>
-
-<file path=ppt/slides/slide5.xml><?xml version="1.0" encoding="utf-8"?>
-<p:sld xmlns:a="http://schemas.openxmlformats.org/drawingml/2006/main" xmlns:p="http://schemas.openxmlformats.org/presentationml/2006/main" xmlns:r="http://schemas.openxmlformats.org/officeDocument/2006/relationships">
-  <p:cSld>
-    <p:spTree>
-      <p:nvGrpSpPr>
-        <p:cNvPr id="1" name=""/>
-        <p:cNvGrpSpPr/>
-        <p:nvPr/>
-      </p:nvGrpSpPr>
-      <p:grpSpPr/>
-      <p:sp>
-        <p:nvSpPr>
-          <p:cNvPr id="2" name="Rectangle 1"/>
-          <p:cNvSpPr/>
-          <p:nvPr/>
-        </p:nvSpPr>
-        <p:spPr>
-          <a:xfrm>
-            <a:off x="0" y="0"/>
-            <a:ext cx="12191695" cy="6858000"/>
-          </a:xfrm>
-          <a:prstGeom prst="rect">
-            <a:avLst/>
-          </a:prstGeom>
-          <a:solidFill>
-            <a:srgbClr val="080A10"/>
-          </a:solidFill>
-          <a:ln>
-            <a:solidFill>
-              <a:srgbClr val="080A10"/>
-            </a:solidFill>
-          </a:ln>
-        </p:spPr>
-        <p:style>
-          <a:lnRef idx="1">
-            <a:schemeClr val="accent1"/>
-          </a:lnRef>
-          <a:fillRef idx="3">
-            <a:schemeClr val="accent1"/>
-          </a:fillRef>
-          <a:effectRef idx="2">
-            <a:schemeClr val="accent1"/>
-          </a:effectRef>
-          <a:fontRef idx="minor">
-            <a:schemeClr val="lt1"/>
-          </a:fontRef>
-        </p:style>
-        <p:txBody>
-          <a:bodyPr rtlCol="0" anchor="ctr"/>
-          <a:lstStyle/>
-          <a:p>
-            <a:pPr algn="ctr"/>
-          </a:p>
-        </p:txBody>
-      </p:sp>
-      <p:sp>
-        <p:nvSpPr>
-          <p:cNvPr id="3" name="TextBox 2"/>
-          <p:cNvSpPr txBox="1"/>
-          <p:nvPr/>
-        </p:nvSpPr>
-        <p:spPr>
-          <a:xfrm>
-            <a:off x="731520" y="365760"/>
-            <a:ext cx="10698480" cy="320040"/>
-          </a:xfrm>
-          <a:prstGeom prst="rect">
-            <a:avLst/>
-          </a:prstGeom>
-          <a:noFill/>
-        </p:spPr>
-        <p:txBody>
-          <a:bodyPr wrap="square">
-            <a:spAutoFit/>
-          </a:bodyPr>
-          <a:lstStyle/>
-          <a:p>
-            <a:pPr>
-              <a:defRPr sz="1100" b="1">
-                <a:solidFill>
-                  <a:srgbClr val="F7B500"/>
-                </a:solidFill>
-              </a:defRPr>
-            </a:pPr>
-            <a:r>
-              <a:t>04 / TECHNICAL PIPELINE</a:t>
-            </a:r>
-          </a:p>
-        </p:txBody>
-      </p:sp>
-      <p:sp>
-        <p:nvSpPr>
-          <p:cNvPr id="4" name="TextBox 3"/>
-          <p:cNvSpPr txBox="1"/>
-          <p:nvPr/>
-        </p:nvSpPr>
-        <p:spPr>
-          <a:xfrm>
-            <a:off x="731520" y="685800"/>
-            <a:ext cx="10698480" cy="640080"/>
-          </a:xfrm>
-          <a:prstGeom prst="rect">
-            <a:avLst/>
-          </a:prstGeom>
-          <a:noFill/>
-        </p:spPr>
-        <p:txBody>
-          <a:bodyPr wrap="square">
-            <a:spAutoFit/>
-          </a:bodyPr>
-          <a:lstStyle/>
-          <a:p>
-            <a:pPr>
-              <a:defRPr sz="2600" b="1">
-                <a:solidFill>
-                  <a:srgbClr val="FFFFFF"/>
-                </a:solidFill>
-              </a:defRPr>
-            </a:pPr>
-            <a:r>
-              <a:t>End-to-End On-Device Pipeline (No Server Required)</a:t>
-            </a:r>
-          </a:p>
-        </p:txBody>
-      </p:sp>
-      <p:sp>
-        <p:nvSpPr>
-          <p:cNvPr id="5" name="Rounded Rectangle 4"/>
-          <p:cNvSpPr/>
-          <p:nvPr/>
-        </p:nvSpPr>
-        <p:spPr>
-          <a:xfrm>
-            <a:off x="731520" y="1828800"/>
-            <a:ext cx="2560320" cy="3931920"/>
-          </a:xfrm>
-          <a:prstGeom prst="roundRect">
-            <a:avLst/>
-          </a:prstGeom>
-          <a:solidFill>
-            <a:srgbClr val="10141E"/>
-          </a:solidFill>
-          <a:ln w="19050">
-            <a:solidFill>
-              <a:srgbClr val="262D41"/>
-            </a:solidFill>
-          </a:ln>
-        </p:spPr>
-        <p:style>
-          <a:lnRef idx="1">
-            <a:schemeClr val="accent1"/>
-          </a:lnRef>
-          <a:fillRef idx="3">
-            <a:schemeClr val="accent1"/>
-          </a:fillRef>
-          <a:effectRef idx="2">
-            <a:schemeClr val="accent1"/>
-          </a:effectRef>
-          <a:fontRef idx="minor">
-            <a:schemeClr val="lt1"/>
-          </a:fontRef>
-        </p:style>
-        <p:txBody>
-          <a:bodyPr rtlCol="0" anchor="ctr" wrap="square"/>
-          <a:lstStyle/>
-          <a:p>
-            <a:pPr algn="ctr">
-              <a:defRPr sz="1600" b="1">
-                <a:solidFill>
-                  <a:srgbClr val="FF3E00"/>
-                </a:solidFill>
-              </a:defRPr>
-            </a:pPr>
-            <a:r>
-              <a:t>Step 1: Vision</a:t>
-            </a:r>
-          </a:p>
-          <a:p>
-            <a:pPr>
-              <a:spcBef>
-                <a:spcPts val="1400"/>
-              </a:spcBef>
-              <a:defRPr sz="1200">
-                <a:solidFill>
-                  <a:srgbClr val="FFFFFF"/>
-                </a:solidFill>
-              </a:defRPr>
-            </a:pPr>
-            <a:r>
-              <a:t>CameraX / Gallery</a:t>
-            </a:r>
-            <a:br/>
-            <a:r>
-              <a:t>On-device Optical Scanner</a:t>
-            </a:r>
-            <a:br/>
-            <a:r>
-              <a:t>Zero network calls</a:t>
-            </a:r>
-          </a:p>
-        </p:txBody>
-      </p:sp>
-      <p:sp>
-        <p:nvSpPr>
-          <p:cNvPr id="6" name="Rounded Rectangle 5"/>
-          <p:cNvSpPr/>
-          <p:nvPr/>
-        </p:nvSpPr>
-        <p:spPr>
-          <a:xfrm>
-            <a:off x="3474720" y="1828800"/>
-            <a:ext cx="2560320" cy="3931920"/>
-          </a:xfrm>
-          <a:prstGeom prst="roundRect">
-            <a:avLst/>
-          </a:prstGeom>
-          <a:solidFill>
-            <a:srgbClr val="10141E"/>
-          </a:solidFill>
-          <a:ln w="19050">
-            <a:solidFill>
-              <a:srgbClr val="262D41"/>
-            </a:solidFill>
-          </a:ln>
-        </p:spPr>
-        <p:style>
-          <a:lnRef idx="1">
-            <a:schemeClr val="accent1"/>
-          </a:lnRef>
-          <a:fillRef idx="3">
-            <a:schemeClr val="accent1"/>
-          </a:fillRef>
-          <a:effectRef idx="2">
-            <a:schemeClr val="accent1"/>
-          </a:effectRef>
-          <a:fontRef idx="minor">
-            <a:schemeClr val="lt1"/>
-          </a:fontRef>
-        </p:style>
-        <p:txBody>
-          <a:bodyPr rtlCol="0" anchor="ctr" wrap="square"/>
-          <a:lstStyle/>
-          <a:p>
-            <a:pPr algn="ctr">
-              <a:defRPr sz="1600" b="1">
-                <a:solidFill>
-                  <a:srgbClr val="F7B500"/>
-                </a:solidFill>
-              </a:defRPr>
-            </a:pPr>
-            <a:r>
-              <a:t>Step 2: OCR</a:t>
-            </a:r>
-          </a:p>
-          <a:p>
-            <a:pPr>
-              <a:spcBef>
-                <a:spcPts val="1400"/>
-              </a:spcBef>
-              <a:defRPr sz="1200">
-                <a:solidFill>
-                  <a:srgbClr val="FFFFFF"/>
-                </a:solidFill>
-              </a:defRPr>
-            </a:pPr>
-            <a:r>
-              <a:t>Google ML Kit (Offline)</a:t>
-            </a:r>
-            <a:br/>
-            <a:r>
-              <a:t>Local text extraction</a:t>
-            </a:r>
-            <a:br/>
-            <a:r>
-              <a:t>Formula &amp; symbol parsing</a:t>
-            </a:r>
-          </a:p>
-        </p:txBody>
-      </p:sp>
-      <p:sp>
-        <p:nvSpPr>
-          <p:cNvPr id="7" name="Rounded Rectangle 6"/>
-          <p:cNvSpPr/>
-          <p:nvPr/>
-        </p:nvSpPr>
-        <p:spPr>
-          <a:xfrm>
-            <a:off x="6217920" y="1828800"/>
-            <a:ext cx="2560320" cy="3931920"/>
-          </a:xfrm>
-          <a:prstGeom prst="roundRect">
-            <a:avLst/>
-          </a:prstGeom>
-          <a:solidFill>
-            <a:srgbClr val="10141E"/>
-          </a:solidFill>
-          <a:ln w="19050">
-            <a:solidFill>
-              <a:srgbClr val="262D41"/>
-            </a:solidFill>
-          </a:ln>
-        </p:spPr>
-        <p:style>
-          <a:lnRef idx="1">
-            <a:schemeClr val="accent1"/>
-          </a:lnRef>
-          <a:fillRef idx="3">
-            <a:schemeClr val="accent1"/>
-          </a:fillRef>
-          <a:effectRef idx="2">
-            <a:schemeClr val="accent1"/>
-          </a:effectRef>
-          <a:fontRef idx="minor">
-            <a:schemeClr val="lt1"/>
-          </a:fontRef>
-        </p:style>
-        <p:txBody>
-          <a:bodyPr rtlCol="0" anchor="ctr" wrap="square"/>
-          <a:lstStyle/>
-          <a:p>
-            <a:pPr algn="ctr">
-              <a:defRPr sz="1600" b="1">
-                <a:solidFill>
-                  <a:srgbClr val="00E5FF"/>
-                </a:solidFill>
-              </a:defRPr>
-            </a:pPr>
-            <a:r>
-              <a:t>Step 3: RAG Store</a:t>
-            </a:r>
-          </a:p>
-          <a:p>
-            <a:pPr>
-              <a:spcBef>
-                <a:spcPts val="1400"/>
-              </a:spcBef>
-              <a:defRPr sz="1200">
-                <a:solidFill>
-                  <a:srgbClr val="FFFFFF"/>
-                </a:solidFill>
-              </a:defRPr>
-            </a:pPr>
-            <a:r>
-              <a:t>NCERT Knowledge Vault</a:t>
-            </a:r>
-            <a:br/>
-            <a:r>
-              <a:t>Local embedding search</a:t>
-            </a:r>
-            <a:br/>
-            <a:r>
-              <a:t>CBSE 9-10 &amp; JEE syllabus</a:t>
-            </a:r>
-          </a:p>
-        </p:txBody>
-      </p:sp>
-      <p:sp>
-        <p:nvSpPr>
-          <p:cNvPr id="8" name="Rounded Rectangle 7"/>
-          <p:cNvSpPr/>
-          <p:nvPr/>
-        </p:nvSpPr>
-        <p:spPr>
-          <a:xfrm>
-            <a:off x="8961120" y="1828800"/>
-            <a:ext cx="2560320" cy="3931920"/>
-          </a:xfrm>
-          <a:prstGeom prst="roundRect">
-            <a:avLst/>
-          </a:prstGeom>
-          <a:solidFill>
-            <a:srgbClr val="10141E"/>
-          </a:solidFill>
-          <a:ln w="19050">
-            <a:solidFill>
-              <a:srgbClr val="262D41"/>
-            </a:solidFill>
-          </a:ln>
-        </p:spPr>
-        <p:style>
-          <a:lnRef idx="1">
-            <a:schemeClr val="accent1"/>
-          </a:lnRef>
-          <a:fillRef idx="3">
-            <a:schemeClr val="accent1"/>
-          </a:fillRef>
-          <a:effectRef idx="2">
-            <a:schemeClr val="accent1"/>
-          </a:effectRef>
-          <a:fontRef idx="minor">
-            <a:schemeClr val="lt1"/>
-          </a:fontRef>
-        </p:style>
-        <p:txBody>
-          <a:bodyPr rtlCol="0" anchor="ctr" wrap="square"/>
-          <a:lstStyle/>
-          <a:p>
-            <a:pPr algn="ctr">
-              <a:defRPr sz="1600" b="1">
-                <a:solidFill>
-                  <a:srgbClr val="00E676"/>
-                </a:solidFill>
-              </a:defRPr>
-            </a:pPr>
-            <a:r>
-              <a:t>Step 4: NPU Engine</a:t>
-            </a:r>
-          </a:p>
-          <a:p>
-            <a:pPr>
-              <a:spcBef>
-                <a:spcPts val="1400"/>
-              </a:spcBef>
-              <a:defRPr sz="1200">
-                <a:solidFill>
-                  <a:srgbClr val="FFFFFF"/>
-                </a:solidFill>
-              </a:defRPr>
-            </a:pPr>
-            <a:r>
-              <a:t>Snapdragon Hexagon</a:t>
-            </a:r>
-            <a:br/>
-            <a:r>
-              <a:t>Local Socratic reasoning</a:t>
-            </a:r>
-            <a:br/>
-            <a:r>
-              <a:t>&lt; 800ms step-by-step steps</a:t>
-            </a:r>
-          </a:p>
-        </p:txBody>
-      </p:sp>
-    </p:spTree>
-  </p:cSld>
-  <p:clrMapOvr>
-    <a:masterClrMapping/>
-  </p:clrMapOvr>
-</p:sld>
-</file>
-
-<file path=ppt/slides/slide6.xml><?xml version="1.0" encoding="utf-8"?>
-<p:sld xmlns:a="http://schemas.openxmlformats.org/drawingml/2006/main" xmlns:p="http://schemas.openxmlformats.org/presentationml/2006/main" xmlns:r="http://schemas.openxmlformats.org/officeDocument/2006/relationships">
-  <p:cSld>
-    <p:spTree>
-      <p:nvGrpSpPr>
-        <p:cNvPr id="1" name=""/>
-        <p:cNvGrpSpPr/>
-        <p:nvPr/>
-      </p:nvGrpSpPr>
-      <p:grpSpPr/>
-      <p:sp>
-        <p:nvSpPr>
-          <p:cNvPr id="2" name="Rectangle 1"/>
-          <p:cNvSpPr/>
-          <p:nvPr/>
-        </p:nvSpPr>
-        <p:spPr>
-          <a:xfrm>
-            <a:off x="0" y="0"/>
-            <a:ext cx="12191695" cy="6858000"/>
-          </a:xfrm>
-          <a:prstGeom prst="rect">
-            <a:avLst/>
-          </a:prstGeom>
-          <a:solidFill>
-            <a:srgbClr val="080A10"/>
-          </a:solidFill>
-          <a:ln>
-            <a:solidFill>
-              <a:srgbClr val="080A10"/>
-            </a:solidFill>
-          </a:ln>
-        </p:spPr>
-        <p:style>
-          <a:lnRef idx="1">
-            <a:schemeClr val="accent1"/>
-          </a:lnRef>
-          <a:fillRef idx="3">
-            <a:schemeClr val="accent1"/>
-          </a:fillRef>
-          <a:effectRef idx="2">
-            <a:schemeClr val="accent1"/>
-          </a:effectRef>
-          <a:fontRef idx="minor">
-            <a:schemeClr val="lt1"/>
-          </a:fontRef>
-        </p:style>
-        <p:txBody>
-          <a:bodyPr rtlCol="0" anchor="ctr"/>
-          <a:lstStyle/>
-          <a:p>
-            <a:pPr algn="ctr"/>
-          </a:p>
-        </p:txBody>
-      </p:sp>
-      <p:sp>
-        <p:nvSpPr>
-          <p:cNvPr id="3" name="TextBox 2"/>
-          <p:cNvSpPr txBox="1"/>
-          <p:nvPr/>
-        </p:nvSpPr>
-        <p:spPr>
-          <a:xfrm>
-            <a:off x="731520" y="365760"/>
-            <a:ext cx="10698480" cy="320040"/>
-          </a:xfrm>
-          <a:prstGeom prst="rect">
-            <a:avLst/>
-          </a:prstGeom>
-          <a:noFill/>
-        </p:spPr>
-        <p:txBody>
-          <a:bodyPr wrap="square">
-            <a:spAutoFit/>
-          </a:bodyPr>
-          <a:lstStyle/>
-          <a:p>
-            <a:pPr>
-              <a:defRPr sz="1100" b="1">
-                <a:solidFill>
-                  <a:srgbClr val="F7B500"/>
-                </a:solidFill>
-              </a:defRPr>
-            </a:pPr>
-            <a:r>
-              <a:t>05 / BENCHMARKS &amp; COMPARISON</a:t>
-            </a:r>
-          </a:p>
-        </p:txBody>
-      </p:sp>
-      <p:sp>
-        <p:nvSpPr>
-          <p:cNvPr id="4" name="TextBox 3"/>
-          <p:cNvSpPr txBox="1"/>
-          <p:nvPr/>
-        </p:nvSpPr>
-        <p:spPr>
-          <a:xfrm>
-            <a:off x="731520" y="685800"/>
-            <a:ext cx="10698480" cy="640080"/>
-          </a:xfrm>
-          <a:prstGeom prst="rect">
-            <a:avLst/>
-          </a:prstGeom>
-          <a:noFill/>
-        </p:spPr>
-        <p:txBody>
-          <a:bodyPr wrap="square">
-            <a:spAutoFit/>
-          </a:bodyPr>
-          <a:lstStyle/>
-          <a:p>
-            <a:pPr>
-              <a:defRPr sz="2600" b="1">
-                <a:solidFill>
-                  <a:srgbClr val="FFFFFF"/>
-                </a:solidFill>
-              </a:defRPr>
-            </a:pPr>
-            <a:r>
-              <a:t>Competitive Matrix: Why EdgeTutor Wins for Indian Students</a:t>
+              <a:t>📊 Implementation Status (Honest Separation)</a:t>
             </a:r>
           </a:p>
         </p:txBody>
       </p:sp>
       <p:graphicFrame>
         <p:nvGraphicFramePr>
-          <p:cNvPr id="5" name="Table 4"/>
+          <p:cNvPr id="7" name="Table 6"/>
           <p:cNvGraphicFramePr>
             <a:graphicFrameLocks noGrp="1"/>
           </p:cNvGraphicFramePr>
           <p:nvPr/>
         </p:nvGraphicFramePr>
         <p:xfrm>
-          <a:off x="731520" y="1645920"/>
-          <a:ext cx="10698480" cy="4389120"/>
+          <a:off x="6080760" y="2286000"/>
+          <a:ext cx="5212080" cy="3749039"/>
         </p:xfrm>
         <a:graphic>
           <a:graphicData uri="http://schemas.openxmlformats.org/drawingml/2006/table">
@@ -5240,27 +4675,25 @@
                 <a:tableStyleId>{5C22544A-7EE6-4342-B048-85BDC9FD1C3A}</a:tableStyleId>
               </a:tblPr>
               <a:tblGrid>
-                <a:gridCol w="2139696"/>
-                <a:gridCol w="2139696"/>
-                <a:gridCol w="2139696"/>
-                <a:gridCol w="2139696"/>
-                <a:gridCol w="2139696"/>
+                <a:gridCol w="1737360"/>
+                <a:gridCol w="1737360"/>
+                <a:gridCol w="1737360"/>
               </a:tblGrid>
-              <a:tr h="731520">
+              <a:tr h="624839">
                 <a:tc>
                   <a:txBody>
                     <a:bodyPr/>
                     <a:lstStyle/>
                     <a:p>
                       <a:pPr>
-                        <a:defRPr sz="1300" b="1">
+                        <a:defRPr sz="1000" b="1">
                           <a:solidFill>
                             <a:srgbClr val="FFFFFF"/>
                           </a:solidFill>
                         </a:defRPr>
                       </a:pPr>
                       <a:r>
-                        <a:t>Feature</a:t>
+                        <a:t>Subsystem</a:t>
                       </a:r>
                     </a:p>
                   </a:txBody>
@@ -5276,14 +4709,14 @@
                     <a:lstStyle/>
                     <a:p>
                       <a:pPr>
-                        <a:defRPr sz="1300" b="1">
+                        <a:defRPr sz="1000" b="1">
                           <a:solidFill>
                             <a:srgbClr val="F7B500"/>
                           </a:solidFill>
                         </a:defRPr>
                       </a:pPr>
                       <a:r>
-                        <a:t>iQOO EdgeTutor</a:t>
+                        <a:t>Demonstrated (Now)</a:t>
                       </a:r>
                     </a:p>
                   </a:txBody>
@@ -5299,60 +4732,14 @@
                     <a:lstStyle/>
                     <a:p>
                       <a:pPr>
-                        <a:defRPr sz="1300" b="1">
+                        <a:defRPr sz="1000" b="1">
                           <a:solidFill>
                             <a:srgbClr val="FFFFFF"/>
                           </a:solidFill>
                         </a:defRPr>
                       </a:pPr>
                       <a:r>
-                        <a:t>ChatGPT Plus</a:t>
-                      </a:r>
-                    </a:p>
-                  </a:txBody>
-                  <a:tcPr>
-                    <a:solidFill>
-                      <a:srgbClr val="10141E"/>
-                    </a:solidFill>
-                  </a:tcPr>
-                </a:tc>
-                <a:tc>
-                  <a:txBody>
-                    <a:bodyPr/>
-                    <a:lstStyle/>
-                    <a:p>
-                      <a:pPr>
-                        <a:defRPr sz="1300" b="1">
-                          <a:solidFill>
-                            <a:srgbClr val="FFFFFF"/>
-                          </a:solidFill>
-                        </a:defRPr>
-                      </a:pPr>
-                      <a:r>
-                        <a:t>Google Lens</a:t>
-                      </a:r>
-                    </a:p>
-                  </a:txBody>
-                  <a:tcPr>
-                    <a:solidFill>
-                      <a:srgbClr val="10141E"/>
-                    </a:solidFill>
-                  </a:tcPr>
-                </a:tc>
-                <a:tc>
-                  <a:txBody>
-                    <a:bodyPr/>
-                    <a:lstStyle/>
-                    <a:p>
-                      <a:pPr>
-                        <a:defRPr sz="1300" b="1">
-                          <a:solidFill>
-                            <a:srgbClr val="FFFFFF"/>
-                          </a:solidFill>
-                        </a:defRPr>
-                      </a:pPr>
-                      <a:r>
-                        <a:t>Doubtnut / Vedantu</a:t>
+                        <a:t>Target Production</a:t>
                       </a:r>
                     </a:p>
                   </a:txBody>
@@ -5363,21 +4750,21 @@
                   </a:tcPr>
                 </a:tc>
               </a:tr>
-              <a:tr h="731520">
+              <a:tr h="624839">
                 <a:tc>
                   <a:txBody>
                     <a:bodyPr/>
                     <a:lstStyle/>
                     <a:p>
                       <a:pPr>
-                        <a:defRPr sz="1100" b="1">
+                        <a:defRPr sz="1000" b="1">
                           <a:solidFill>
                             <a:srgbClr val="FFFFFF"/>
                           </a:solidFill>
                         </a:defRPr>
                       </a:pPr>
                       <a:r>
-                        <a:t>Internet Required?</a:t>
+                        <a:t>Network</a:t>
                       </a:r>
                     </a:p>
                   </a:txBody>
@@ -5393,14 +4780,14 @@
                     <a:lstStyle/>
                     <a:p>
                       <a:pPr>
-                        <a:defRPr sz="1100" b="1">
+                        <a:defRPr sz="1000" b="0">
                           <a:solidFill>
                             <a:srgbClr val="00E676"/>
                           </a:solidFill>
                         </a:defRPr>
                       </a:pPr>
                       <a:r>
-                        <a:t>❌ ZERO (Airplane Mode)</a:t>
+                        <a:t>0 KB (No Internet Manifest)</a:t>
                       </a:r>
                     </a:p>
                   </a:txBody>
@@ -5416,14 +4803,39 @@
                     <a:lstStyle/>
                     <a:p>
                       <a:pPr>
-                        <a:defRPr sz="1100" b="0">
+                        <a:defRPr sz="1000" b="0">
                           <a:solidFill>
                             <a:srgbClr val="FFFFFF"/>
                           </a:solidFill>
                         </a:defRPr>
                       </a:pPr>
                       <a:r>
-                        <a:t>✅ Mandatory High Speed</a:t>
+                        <a:t>0 KB (Strict Air-Gapped)</a:t>
+                      </a:r>
+                    </a:p>
+                  </a:txBody>
+                  <a:tcPr>
+                    <a:solidFill>
+                      <a:srgbClr val="0C0F18"/>
+                    </a:solidFill>
+                  </a:tcPr>
+                </a:tc>
+              </a:tr>
+              <a:tr h="624839">
+                <a:tc>
+                  <a:txBody>
+                    <a:bodyPr/>
+                    <a:lstStyle/>
+                    <a:p>
+                      <a:pPr>
+                        <a:defRPr sz="1000" b="1">
+                          <a:solidFill>
+                            <a:srgbClr val="FFFFFF"/>
+                          </a:solidFill>
+                        </a:defRPr>
+                      </a:pPr>
+                      <a:r>
+                        <a:t>Vision / OCR</a:t>
                       </a:r>
                     </a:p>
                   </a:txBody>
@@ -5439,14 +4851,14 @@
                     <a:lstStyle/>
                     <a:p>
                       <a:pPr>
-                        <a:defRPr sz="1100" b="0">
+                        <a:defRPr sz="1000" b="0">
                           <a:solidFill>
-                            <a:srgbClr val="FFFFFF"/>
+                            <a:srgbClr val="00E676"/>
                           </a:solidFill>
                         </a:defRPr>
                       </a:pPr>
                       <a:r>
-                        <a:t>✅ Mandatory High Speed</a:t>
+                        <a:t>ML Kit (Offline Local)</a:t>
                       </a:r>
                     </a:p>
                   </a:txBody>
@@ -5462,14 +4874,14 @@
                     <a:lstStyle/>
                     <a:p>
                       <a:pPr>
-                        <a:defRPr sz="1100" b="0">
+                        <a:defRPr sz="1000" b="0">
                           <a:solidFill>
                             <a:srgbClr val="FFFFFF"/>
                           </a:solidFill>
                         </a:defRPr>
                       </a:pPr>
                       <a:r>
-                        <a:t>✅ Mandatory Active Data</a:t>
+                        <a:t>CameraX + ML Kit</a:t>
                       </a:r>
                     </a:p>
                   </a:txBody>
@@ -5480,21 +4892,21 @@
                   </a:tcPr>
                 </a:tc>
               </a:tr>
-              <a:tr h="731520">
+              <a:tr h="624839">
                 <a:tc>
                   <a:txBody>
                     <a:bodyPr/>
                     <a:lstStyle/>
                     <a:p>
                       <a:pPr>
-                        <a:defRPr sz="1100" b="1">
+                        <a:defRPr sz="1000" b="1">
                           <a:solidFill>
                             <a:srgbClr val="FFFFFF"/>
                           </a:solidFill>
                         </a:defRPr>
                       </a:pPr>
                       <a:r>
-                        <a:t>Inference Location</a:t>
+                        <a:t>Curriculum</a:t>
                       </a:r>
                     </a:p>
                   </a:txBody>
@@ -5510,14 +4922,14 @@
                     <a:lstStyle/>
                     <a:p>
                       <a:pPr>
-                        <a:defRPr sz="1100" b="1">
+                        <a:defRPr sz="1000" b="0">
                           <a:solidFill>
                             <a:srgbClr val="00E676"/>
                           </a:solidFill>
                         </a:defRPr>
                       </a:pPr>
                       <a:r>
-                        <a:t>📱 On-Device NPU</a:t>
+                        <a:t>CBSE 9-10 &amp; JEE Vault</a:t>
                       </a:r>
                     </a:p>
                   </a:txBody>
@@ -5533,14 +4945,39 @@
                     <a:lstStyle/>
                     <a:p>
                       <a:pPr>
-                        <a:defRPr sz="1100" b="0">
+                        <a:defRPr sz="1000" b="0">
                           <a:solidFill>
                             <a:srgbClr val="FFFFFF"/>
                           </a:solidFill>
                         </a:defRPr>
                       </a:pPr>
                       <a:r>
-                        <a:t>☁️ US Cloud Servers</a:t>
+                        <a:t>Full K-12 Vector Store</a:t>
+                      </a:r>
+                    </a:p>
+                  </a:txBody>
+                  <a:tcPr>
+                    <a:solidFill>
+                      <a:srgbClr val="0C0F18"/>
+                    </a:solidFill>
+                  </a:tcPr>
+                </a:tc>
+              </a:tr>
+              <a:tr h="624839">
+                <a:tc>
+                  <a:txBody>
+                    <a:bodyPr/>
+                    <a:lstStyle/>
+                    <a:p>
+                      <a:pPr>
+                        <a:defRPr sz="1000" b="1">
+                          <a:solidFill>
+                            <a:srgbClr val="FFFFFF"/>
+                          </a:solidFill>
+                        </a:defRPr>
+                      </a:pPr>
+                      <a:r>
+                        <a:t>SLM Runtime</a:t>
                       </a:r>
                     </a:p>
                   </a:txBody>
@@ -5556,14 +4993,14 @@
                     <a:lstStyle/>
                     <a:p>
                       <a:pPr>
-                        <a:defRPr sz="1100" b="0">
+                        <a:defRPr sz="1000" b="0">
                           <a:solidFill>
-                            <a:srgbClr val="FFFFFF"/>
+                            <a:srgbClr val="00E676"/>
                           </a:solidFill>
                         </a:defRPr>
                       </a:pPr>
                       <a:r>
-                        <a:t>☁️ Google Cloud Vision</a:t>
+                        <a:t>Socratic Pipeline Emulator</a:t>
                       </a:r>
                     </a:p>
                   </a:txBody>
@@ -5579,14 +5016,14 @@
                     <a:lstStyle/>
                     <a:p>
                       <a:pPr>
-                        <a:defRPr sz="1100" b="0">
+                        <a:defRPr sz="1000" b="0">
                           <a:solidFill>
                             <a:srgbClr val="FFFFFF"/>
                           </a:solidFill>
                         </a:defRPr>
                       </a:pPr>
                       <a:r>
-                        <a:t>☁️ Commercial Servers</a:t>
+                        <a:t>Qualcomm QNN / MediaPipe</a:t>
                       </a:r>
                     </a:p>
                   </a:txBody>
@@ -5597,21 +5034,21 @@
                   </a:tcPr>
                 </a:tc>
               </a:tr>
-              <a:tr h="731520">
+              <a:tr h="624844">
                 <a:tc>
                   <a:txBody>
                     <a:bodyPr/>
                     <a:lstStyle/>
                     <a:p>
                       <a:pPr>
-                        <a:defRPr sz="1100" b="1">
+                        <a:defRPr sz="1000" b="1">
                           <a:solidFill>
                             <a:srgbClr val="FFFFFF"/>
                           </a:solidFill>
                         </a:defRPr>
                       </a:pPr>
                       <a:r>
-                        <a:t>Response Latency</a:t>
+                        <a:t>Speed</a:t>
                       </a:r>
                     </a:p>
                   </a:txBody>
@@ -5627,14 +5064,14 @@
                     <a:lstStyle/>
                     <a:p>
                       <a:pPr>
-                        <a:defRPr sz="1100" b="1">
+                        <a:defRPr sz="1000" b="0">
                           <a:solidFill>
                             <a:srgbClr val="00E676"/>
                           </a:solidFill>
                         </a:defRPr>
                       </a:pPr>
                       <a:r>
-                        <a:t>⚡ &lt; 800 ms (Instant)</a:t>
+                        <a:t>Interactive Baseline</a:t>
                       </a:r>
                     </a:p>
                   </a:txBody>
@@ -5650,294 +5087,14 @@
                     <a:lstStyle/>
                     <a:p>
                       <a:pPr>
-                        <a:defRPr sz="1100" b="0">
+                        <a:defRPr sz="1000" b="0">
                           <a:solidFill>
                             <a:srgbClr val="FFFFFF"/>
                           </a:solidFill>
                         </a:defRPr>
                       </a:pPr>
                       <a:r>
-                        <a:t>⏳ 5 - 10 Seconds</a:t>
-                      </a:r>
-                    </a:p>
-                  </a:txBody>
-                  <a:tcPr>
-                    <a:solidFill>
-                      <a:srgbClr val="0C0F18"/>
-                    </a:solidFill>
-                  </a:tcPr>
-                </a:tc>
-                <a:tc>
-                  <a:txBody>
-                    <a:bodyPr/>
-                    <a:lstStyle/>
-                    <a:p>
-                      <a:pPr>
-                        <a:defRPr sz="1100" b="0">
-                          <a:solidFill>
-                            <a:srgbClr val="FFFFFF"/>
-                          </a:solidFill>
-                        </a:defRPr>
-                      </a:pPr>
-                      <a:r>
-                        <a:t>⏳ 3 - 6 Seconds</a:t>
-                      </a:r>
-                    </a:p>
-                  </a:txBody>
-                  <a:tcPr>
-                    <a:solidFill>
-                      <a:srgbClr val="0C0F18"/>
-                    </a:solidFill>
-                  </a:tcPr>
-                </a:tc>
-                <a:tc>
-                  <a:txBody>
-                    <a:bodyPr/>
-                    <a:lstStyle/>
-                    <a:p>
-                      <a:pPr>
-                        <a:defRPr sz="1100" b="0">
-                          <a:solidFill>
-                            <a:srgbClr val="FFFFFF"/>
-                          </a:solidFill>
-                        </a:defRPr>
-                      </a:pPr>
-                      <a:r>
-                        <a:t>⏳ 8 - 15 Seconds</a:t>
-                      </a:r>
-                    </a:p>
-                  </a:txBody>
-                  <a:tcPr>
-                    <a:solidFill>
-                      <a:srgbClr val="0C0F18"/>
-                    </a:solidFill>
-                  </a:tcPr>
-                </a:tc>
-              </a:tr>
-              <a:tr h="731520">
-                <a:tc>
-                  <a:txBody>
-                    <a:bodyPr/>
-                    <a:lstStyle/>
-                    <a:p>
-                      <a:pPr>
-                        <a:defRPr sz="1100" b="1">
-                          <a:solidFill>
-                            <a:srgbClr val="FFFFFF"/>
-                          </a:solidFill>
-                        </a:defRPr>
-                      </a:pPr>
-                      <a:r>
-                        <a:t>Student Distraction</a:t>
-                      </a:r>
-                    </a:p>
-                  </a:txBody>
-                  <a:tcPr>
-                    <a:solidFill>
-                      <a:srgbClr val="0C0F18"/>
-                    </a:solidFill>
-                  </a:tcPr>
-                </a:tc>
-                <a:tc>
-                  <a:txBody>
-                    <a:bodyPr/>
-                    <a:lstStyle/>
-                    <a:p>
-                      <a:pPr>
-                        <a:defRPr sz="1100" b="1">
-                          <a:solidFill>
-                            <a:srgbClr val="00E676"/>
-                          </a:solidFill>
-                        </a:defRPr>
-                      </a:pPr>
-                      <a:r>
-                        <a:t>🛡️ Zero (Offline Focus)</a:t>
-                      </a:r>
-                    </a:p>
-                  </a:txBody>
-                  <a:tcPr>
-                    <a:solidFill>
-                      <a:srgbClr val="0C0F18"/>
-                    </a:solidFill>
-                  </a:tcPr>
-                </a:tc>
-                <a:tc>
-                  <a:txBody>
-                    <a:bodyPr/>
-                    <a:lstStyle/>
-                    <a:p>
-                      <a:pPr>
-                        <a:defRPr sz="1100" b="0">
-                          <a:solidFill>
-                            <a:srgbClr val="A5AFC3"/>
-                          </a:solidFill>
-                        </a:defRPr>
-                      </a:pPr>
-                      <a:r>
-                        <a:t>⚠️ High (Browser/Apps)</a:t>
-                      </a:r>
-                    </a:p>
-                  </a:txBody>
-                  <a:tcPr>
-                    <a:solidFill>
-                      <a:srgbClr val="0C0F18"/>
-                    </a:solidFill>
-                  </a:tcPr>
-                </a:tc>
-                <a:tc>
-                  <a:txBody>
-                    <a:bodyPr/>
-                    <a:lstStyle/>
-                    <a:p>
-                      <a:pPr>
-                        <a:defRPr sz="1100" b="0">
-                          <a:solidFill>
-                            <a:srgbClr val="A5AFC3"/>
-                          </a:solidFill>
-                        </a:defRPr>
-                      </a:pPr>
-                      <a:r>
-                        <a:t>⚠️ Moderate</a:t>
-                      </a:r>
-                    </a:p>
-                  </a:txBody>
-                  <a:tcPr>
-                    <a:solidFill>
-                      <a:srgbClr val="0C0F18"/>
-                    </a:solidFill>
-                  </a:tcPr>
-                </a:tc>
-                <a:tc>
-                  <a:txBody>
-                    <a:bodyPr/>
-                    <a:lstStyle/>
-                    <a:p>
-                      <a:pPr>
-                        <a:defRPr sz="1100" b="0">
-                          <a:solidFill>
-                            <a:srgbClr val="A5AFC3"/>
-                          </a:solidFill>
-                        </a:defRPr>
-                      </a:pPr>
-                      <a:r>
-                        <a:t>⚠️ Ads &amp; Notifications</a:t>
-                      </a:r>
-                    </a:p>
-                  </a:txBody>
-                  <a:tcPr>
-                    <a:solidFill>
-                      <a:srgbClr val="0C0F18"/>
-                    </a:solidFill>
-                  </a:tcPr>
-                </a:tc>
-              </a:tr>
-              <a:tr h="731520">
-                <a:tc>
-                  <a:txBody>
-                    <a:bodyPr/>
-                    <a:lstStyle/>
-                    <a:p>
-                      <a:pPr>
-                        <a:defRPr sz="1100" b="1">
-                          <a:solidFill>
-                            <a:srgbClr val="FFFFFF"/>
-                          </a:solidFill>
-                        </a:defRPr>
-                      </a:pPr>
-                      <a:r>
-                        <a:t>Cost to Student</a:t>
-                      </a:r>
-                    </a:p>
-                  </a:txBody>
-                  <a:tcPr>
-                    <a:solidFill>
-                      <a:srgbClr val="0C0F18"/>
-                    </a:solidFill>
-                  </a:tcPr>
-                </a:tc>
-                <a:tc>
-                  <a:txBody>
-                    <a:bodyPr/>
-                    <a:lstStyle/>
-                    <a:p>
-                      <a:pPr>
-                        <a:defRPr sz="1100" b="1">
-                          <a:solidFill>
-                            <a:srgbClr val="00E676"/>
-                          </a:solidFill>
-                        </a:defRPr>
-                      </a:pPr>
-                      <a:r>
-                        <a:t>🆓 100% Free Forever</a:t>
-                      </a:r>
-                    </a:p>
-                  </a:txBody>
-                  <a:tcPr>
-                    <a:solidFill>
-                      <a:srgbClr val="0C0F18"/>
-                    </a:solidFill>
-                  </a:tcPr>
-                </a:tc>
-                <a:tc>
-                  <a:txBody>
-                    <a:bodyPr/>
-                    <a:lstStyle/>
-                    <a:p>
-                      <a:pPr>
-                        <a:defRPr sz="1100" b="0">
-                          <a:solidFill>
-                            <a:srgbClr val="A5AFC3"/>
-                          </a:solidFill>
-                        </a:defRPr>
-                      </a:pPr>
-                      <a:r>
-                        <a:t>💰 ₹1,999 / Month</a:t>
-                      </a:r>
-                    </a:p>
-                  </a:txBody>
-                  <a:tcPr>
-                    <a:solidFill>
-                      <a:srgbClr val="0C0F18"/>
-                    </a:solidFill>
-                  </a:tcPr>
-                </a:tc>
-                <a:tc>
-                  <a:txBody>
-                    <a:bodyPr/>
-                    <a:lstStyle/>
-                    <a:p>
-                      <a:pPr>
-                        <a:defRPr sz="1100" b="0">
-                          <a:solidFill>
-                            <a:srgbClr val="FFFFFF"/>
-                          </a:solidFill>
-                        </a:defRPr>
-                      </a:pPr>
-                      <a:r>
-                        <a:t>🆓 Ad-Supported</a:t>
-                      </a:r>
-                    </a:p>
-                  </a:txBody>
-                  <a:tcPr>
-                    <a:solidFill>
-                      <a:srgbClr val="0C0F18"/>
-                    </a:solidFill>
-                  </a:tcPr>
-                </a:tc>
-                <a:tc>
-                  <a:txBody>
-                    <a:bodyPr/>
-                    <a:lstStyle/>
-                    <a:p>
-                      <a:pPr>
-                        <a:defRPr sz="1100" b="0">
-                          <a:solidFill>
-                            <a:srgbClr val="A5AFC3"/>
-                          </a:solidFill>
-                        </a:defRPr>
-                      </a:pPr>
-                      <a:r>
-                        <a:t>💰 ₹500 - ₹2,000 / Mo</a:t>
+                        <a:t>Target: ≥24 tok/s</a:t>
                       </a:r>
                     </a:p>
                   </a:txBody>
@@ -5960,7 +5117,7 @@
 </p:sld>
 </file>
 
-<file path=ppt/slides/slide7.xml><?xml version="1.0" encoding="utf-8"?>
+<file path=ppt/slides/slide5.xml><?xml version="1.0" encoding="utf-8"?>
 <p:sld xmlns:a="http://schemas.openxmlformats.org/drawingml/2006/main" xmlns:p="http://schemas.openxmlformats.org/presentationml/2006/main" xmlns:r="http://schemas.openxmlformats.org/officeDocument/2006/relationships">
   <p:cSld>
     <p:spTree>
@@ -6045,7 +5202,7 @@
               </a:defRPr>
             </a:pPr>
             <a:r>
-              <a:t>06 / SUBMISSION &amp; ROADMAP</a:t>
+              <a:t>04 / DEMO &amp; CONCLUSION</a:t>
             </a:r>
           </a:p>
         </p:txBody>
@@ -6080,7 +5237,7 @@
               </a:defRPr>
             </a:pPr>
             <a:r>
-              <a:t>60-Second Live Stage Demo &amp; Future Roadmap</a:t>
+              <a:t>The 60-Second Live Stage Demo &amp; Impact</a:t>
             </a:r>
           </a:p>
         </p:txBody>
@@ -6094,7 +5251,7 @@
         <p:spPr>
           <a:xfrm>
             <a:off x="731520" y="1645920"/>
-            <a:ext cx="5120640" cy="4389120"/>
+            <a:ext cx="5120640" cy="4480560"/>
           </a:xfrm>
           <a:prstGeom prst="roundRect">
             <a:avLst/>
@@ -6134,7 +5291,7 @@
               </a:defRPr>
             </a:pPr>
             <a:r>
-              <a:t>🎬 The 60-Second 'Airplane Mode' Wow Factor</a:t>
+              <a:t>🎬 The 60-Second Airplane Mode Demo</a:t>
             </a:r>
           </a:p>
           <a:p>
@@ -6149,38 +5306,50 @@
               </a:defRPr>
             </a:pPr>
             <a:r>
-              <a:t>1. 0:00-0:10 | The Proof:</a:t>
+              <a:t>1. 0:00 - 0:15 | The Physical Proof:</a:t>
             </a:r>
             <a:br/>
             <a:r>
-              <a:t>   Swipe down status bar, turn on Airplane Mode (0 KB/s badge turns green).</a:t>
+              <a:t>   Swipe notification shade, toggle Airplane Mode.</a:t>
+            </a:r>
+            <a:br/>
+            <a:r>
+              <a:t>   Status badge reacts instantly: 'AIRPLANE ON • 0 KB'.</a:t>
             </a:r>
             <a:br/>
             <a:br/>
             <a:r>
-              <a:t>2. 0:10-0:30 | The Scan:</a:t>
+              <a:t>2. 0:15 - 0:35 | The Scan &amp; Retrieval:</a:t>
             </a:r>
             <a:br/>
             <a:r>
-              <a:t>   Point camera at complex textbook physics question (e.g. Incline Friction).</a:t>
+              <a:t>   Point camera at textbook incline physics problem.</a:t>
+            </a:r>
+            <a:br/>
+            <a:r>
+              <a:t>   Offline OCR extracts question; local RAG finds concept.</a:t>
             </a:r>
             <a:br/>
             <a:br/>
             <a:r>
-              <a:t>3. 0:30-0:50 | The NPU Magic:</a:t>
+              <a:t>3. 0:35 - 0:50 | Socratic Dialogue:</a:t>
             </a:r>
             <a:br/>
             <a:r>
-              <a:t>   Instant step-by-step Socratic breakdown rendered with real KaTeX formulas.</a:t>
+              <a:t>   EdgeTutor asks: 'What forces act along the slope?'</a:t>
+            </a:r>
+            <a:br/>
+            <a:r>
+              <a:t>   Student guided step-by-step with KaTeX formulas.</a:t>
             </a:r>
             <a:br/>
             <a:br/>
             <a:r>
-              <a:t>4. 0:50-1:00 | The Impact:</a:t>
+              <a:t>4. 0:50 - 1:00 | Verifiable 0 KB Result:</a:t>
             </a:r>
             <a:br/>
             <a:r>
-              <a:t>   Browse CBSE 9-10 &amp; JEE materials vault with zero buffering anywhere.</a:t>
+              <a:t>   Show system network stats: Exactly 0 KB consumed.</a:t>
             </a:r>
           </a:p>
         </p:txBody>
@@ -6194,7 +5363,7 @@
         <p:spPr>
           <a:xfrm>
             <a:off x="6217920" y="1645920"/>
-            <a:ext cx="5212080" cy="4389120"/>
+            <a:ext cx="5212080" cy="4480560"/>
           </a:xfrm>
           <a:prstGeom prst="roundRect">
             <a:avLst/>
@@ -6234,7 +5403,7 @@
               </a:defRPr>
             </a:pPr>
             <a:r>
-              <a:t>🚀 Future Roadmap &amp; Scaling</a:t>
+              <a:t>🚀 Strategic Impact &amp; Brand Value</a:t>
             </a:r>
           </a:p>
           <a:p>
@@ -6249,29 +5418,42 @@
               </a:defRPr>
             </a:pPr>
             <a:r>
-              <a:t>🌐 Vernacular Voice Mentor (Q3 2026):</a:t>
+              <a:t>• Redefines Performance Beyond Gaming:</a:t>
             </a:r>
             <a:br/>
             <a:r>
-              <a:t>   Integrate offline on-device Whisper models for voice doubt queries in Telugu, Hindi, and Tamil.</a:t>
+              <a:t>  Proves iQOO silicon isn't just for BGMI—it's India's smartest productivity engine.</a:t>
             </a:r>
             <a:br/>
             <a:br/>
             <a:r>
-              <a:t>📐 Interactive 3D AR Models (Q4 2026):</a:t>
+              <a:t>• The 'Parent-Approved' Buying Decision:</a:t>
             </a:r>
             <a:br/>
             <a:r>
-              <a:t>   Leverage Adreno GPU to render interactive 3D physics experiments (free-body diagrams, optics lenses).</a:t>
+              <a:t>  Parents gladly invest in an iQOO phone when it serves as a distraction-free offline study mentor.</a:t>
             </a:r>
             <a:br/>
             <a:br/>
             <a:r>
-              <a:t>🤝 Pre-Loaded iQOO System Feature:</a:t>
+              <a:t>• Potential Out-of-the-Box Feature:</a:t>
             </a:r>
             <a:br/>
             <a:r>
-              <a:t>   Opportunity to ship EdgeTutor as a default Monster Feature on iQOO Z &amp; Neo series smartphones across India.</a:t>
+              <a:t>  Strong candidate for pre-loading as a flagship educational capability on FuntouchOS.</a:t>
+            </a:r>
+            <a:br/>
+            <a:br/>
+            <a:r>
+              <a:t>🌟 Final Punchline:</a:t>
+            </a:r>
+            <a:br/>
+            <a:r>
+              <a:t>  'Don't distract students with the internet.</a:t>
+            </a:r>
+            <a:br/>
+            <a:r>
+              <a:t>   Empower them with On-Device AI.'</a:t>
             </a:r>
           </a:p>
         </p:txBody>

</xml_diff>